<commit_message>
Upgrade NEXA to verified Granite 2.533B and harden planning with broad validation
</commit_message>
<xml_diff>
--- a/submission/outside-geoai-hackathon.pptx
+++ b/submission/outside-geoai-hackathon.pptx
@@ -2,18 +2,18 @@
 <file path=ppt/presentation.xml><?xml version="1.0" encoding="utf-8"?>
 <p:presentation xmlns:p="http://schemas.openxmlformats.org/presentationml/2006/main">
   <p:sldMasterIdLst>
-    <p:sldMasterId xmlns:r="http://schemas.openxmlformats.org/officeDocument/2006/relationships" id="2147483648" r:id="R66ff7aa21e9e448f"/>
+    <p:sldMasterId xmlns:r="http://schemas.openxmlformats.org/officeDocument/2006/relationships" id="2147483648" r:id="R7c6291ef57364618"/>
   </p:sldMasterIdLst>
   <p:notesMasterIdLst>
-    <p:notesMasterId xmlns:r="http://schemas.openxmlformats.org/officeDocument/2006/relationships" r:id="R32b598ed67054295"/>
+    <p:notesMasterId xmlns:r="http://schemas.openxmlformats.org/officeDocument/2006/relationships" r:id="Rc03fdf316c1448c3"/>
   </p:notesMasterIdLst>
   <p:sldIdLst>
-    <p:sldId xmlns:r="http://schemas.openxmlformats.org/officeDocument/2006/relationships" id="256" r:id="R1c273d0730ab4f03"/>
-    <p:sldId xmlns:r="http://schemas.openxmlformats.org/officeDocument/2006/relationships" id="257" r:id="Ra60b794b8eb540d8"/>
-    <p:sldId xmlns:r="http://schemas.openxmlformats.org/officeDocument/2006/relationships" id="258" r:id="R1b8e153080524cff"/>
-    <p:sldId xmlns:r="http://schemas.openxmlformats.org/officeDocument/2006/relationships" id="259" r:id="R4b9a285a72e54a1e"/>
-    <p:sldId xmlns:r="http://schemas.openxmlformats.org/officeDocument/2006/relationships" id="260" r:id="Ra53e6ff59a684e36"/>
-    <p:sldId xmlns:r="http://schemas.openxmlformats.org/officeDocument/2006/relationships" id="261" r:id="R10b2a0144f594817"/>
+    <p:sldId xmlns:r="http://schemas.openxmlformats.org/officeDocument/2006/relationships" id="256" r:id="R82e7cfc92d424078"/>
+    <p:sldId xmlns:r="http://schemas.openxmlformats.org/officeDocument/2006/relationships" id="257" r:id="Ra6dc3862089f465e"/>
+    <p:sldId xmlns:r="http://schemas.openxmlformats.org/officeDocument/2006/relationships" id="258" r:id="Rfe3db5334f554120"/>
+    <p:sldId xmlns:r="http://schemas.openxmlformats.org/officeDocument/2006/relationships" id="259" r:id="R343a8c9d1bd04a34"/>
+    <p:sldId xmlns:r="http://schemas.openxmlformats.org/officeDocument/2006/relationships" id="260" r:id="Re481f8f30a444c2d"/>
+    <p:sldId xmlns:r="http://schemas.openxmlformats.org/officeDocument/2006/relationships" id="261" r:id="Rcd3978a8fba44d8d"/>
   </p:sldIdLst>
   <p:sldSz cx="12192000" cy="6858000"/>
   <p:notesSz cx="6858000" cy="9144000"/>
@@ -447,7 +447,7 @@
           <a:lstStyle xmlns:a="http://schemas.openxmlformats.org/drawingml/2006/main"/>
           <a:p xmlns:a="http://schemas.openxmlformats.org/drawingml/2006/main">
             <a:r>
-              <a:t>Challenge source: geoai-hackathon-2026-rulebook.pdf, pages 1–6. Project source: https://github.com/F4K3S4T1SH/geoai-outdoor-assistant . Uses an unchanged self-run small model. No fine-tuning.</a:t>
+              <a:t>Team NEXA, account F4K3S4T1SH. Challenge: supplied geoai-hackathon-2026-rulebook.pdf pages 1–6. Code: https://github.com/F4K3S4T1SH/geoai-outdoor-assistant . An unchanged IBM Granite small model is self-run; no team fine-tuning.</a:t>
             </a:r>
           </a:p>
         </p:txBody>
@@ -657,7 +657,7 @@
           <a:lstStyle xmlns:a="http://schemas.openxmlformats.org/drawingml/2006/main"/>
           <a:p xmlns:a="http://schemas.openxmlformats.org/drawingml/2006/main">
             <a:r>
-              <a:t>Base model: https://huggingface.co/Qwen/Qwen2.5-1.5B-Instruct . GGUF upstream: https://huggingface.co/Qwen/Qwen2.5-1.5B-Instruct-GGUF revision 91cad51170dc346986eccefdc2dd33a9da36ead9 . Exact artifact SHA256: 6a1a2eb6d15622bf3c96857206351ba97e1af16c30d7a74ee38970e434e9407e . Team repository: https://huggingface.co/F4K3S4T1SH/geoai-outdoor-model . Licence Apache 2.0. GGUF loading reference: https://huggingface.co/docs/transformers/quantization/gguf . OpenAI Codex helped write the code; no hosted large model runs in the assistant.</a:t>
+              <a:t>Base: https://huggingface.co/ibm-granite/granite-3.3-2b-instruct revision 707f574c62054322f6b5b04b6d075f0a8f05e0f0. Official IBM quantization: https://huggingface.co/ibm-granite/granite-3.3-2b-instruct-GGUF revision 7cdf86ccd1f1bb3491c9b7017b033f2e51367397. Q4_K_M SHA256 ac71e9e32c0bea919b409c5918f69ca74339854b0319c5065e4e9fb6d95c4852. Actual logical tensor count: 2,533,539,840 parameters, 362 tensors, tied embeddings stored once; submission/model-parameter-count.json. Apache 2.0. No team fine-tuning. Schema-constrained extraction, generic validation and evidence-only comparison. Local llama.cpp b11823, 4096 context, temperature zero, reasoning disabled. OpenAI Codex assisted development; no hosted large model in runtime. Model repository: https://huggingface.co/F4K3S4T1SH/geoai-outdoor-model .</a:t>
             </a:r>
           </a:p>
         </p:txBody>
@@ -3240,12 +3240,12 @@
   </p:cSld>
   <p:clrMap bg1="lt1" tx1="dk1" bg2="lt2" tx2="dk2" accent1="accent1" accent2="accent2" accent3="accent3" accent4="accent4" accent5="accent5" accent6="accent6" hlink="hlink" folHlink="folHlink"/>
   <p:sldLayoutIdLst>
-    <p:sldLayoutId xmlns:r="http://schemas.openxmlformats.org/officeDocument/2006/relationships" id="2147483649" r:id="R1df6f3f5cd5d4be1"/>
-    <p:sldLayoutId xmlns:r="http://schemas.openxmlformats.org/officeDocument/2006/relationships" id="2147483650" r:id="Rcaf966f1d7f244e4"/>
-    <p:sldLayoutId xmlns:r="http://schemas.openxmlformats.org/officeDocument/2006/relationships" id="2147483651" r:id="R53bea484db7f4bec"/>
-    <p:sldLayoutId xmlns:r="http://schemas.openxmlformats.org/officeDocument/2006/relationships" id="2147483652" r:id="R6d9b71a7cfe848e0"/>
-    <p:sldLayoutId xmlns:r="http://schemas.openxmlformats.org/officeDocument/2006/relationships" id="2147483653" r:id="R17d732c6bbb44be8"/>
-    <p:sldLayoutId xmlns:r="http://schemas.openxmlformats.org/officeDocument/2006/relationships" id="2147483654" r:id="R855557bc41184270"/>
+    <p:sldLayoutId xmlns:r="http://schemas.openxmlformats.org/officeDocument/2006/relationships" id="2147483649" r:id="Raf2a5e12fdd4412c"/>
+    <p:sldLayoutId xmlns:r="http://schemas.openxmlformats.org/officeDocument/2006/relationships" id="2147483650" r:id="Rb122e828351d4d4f"/>
+    <p:sldLayoutId xmlns:r="http://schemas.openxmlformats.org/officeDocument/2006/relationships" id="2147483651" r:id="Ra9691fe920bd4057"/>
+    <p:sldLayoutId xmlns:r="http://schemas.openxmlformats.org/officeDocument/2006/relationships" id="2147483652" r:id="R1cbb1c1f87d04e87"/>
+    <p:sldLayoutId xmlns:r="http://schemas.openxmlformats.org/officeDocument/2006/relationships" id="2147483653" r:id="R9a116031efe74419"/>
+    <p:sldLayoutId xmlns:r="http://schemas.openxmlformats.org/officeDocument/2006/relationships" id="2147483654" r:id="Ra4afed0c5abb42b3"/>
   </p:sldLayoutIdLst>
   <p:txStyles>
     <p:titleStyle>
@@ -4533,7 +4533,7 @@
                   <a:srgbClr val="697663"/>
                 </a:solidFill>
               </a:rPr>
-              <a:t>F4K3S4T1SH</a:t>
+              <a:t>Team NEXA · F4K3S4T1SH</a:t>
             </a:r>
           </a:p>
           <a:p xmlns:a="http://schemas.openxmlformats.org/drawingml/2006/main">
@@ -6838,7 +6838,7 @@
                   <a:srgbClr val="245B48"/>
                 </a:solidFill>
               </a:rPr>
-              <a:t>Profiles tighten prototype limits. Nearby roads, wind, water and greenery affect scoring and cautions.</a:t>
+              <a:t>Profiles tighten prototype limits. Roads, industry, wind, water and greenery affect scores and cautions.</a:t>
             </a:r>
           </a:p>
         </p:txBody>
@@ -7347,7 +7347,7 @@
                   <a:srgbClr val="245B48"/>
                 </a:solidFill>
               </a:rPr>
-              <a:t>1.54B</a:t>
+              <a:t>2.533B</a:t>
             </a:r>
           </a:p>
         </p:txBody>
@@ -7467,7 +7467,7 @@
                   <a:srgbClr val="697663"/>
                 </a:solidFill>
               </a:rPr>
-              <a:t>parameters · below the 3B limit</a:t>
+              <a:t>actual parameters · below the 3B limit</a:t>
             </a:r>
           </a:p>
         </p:txBody>
@@ -7587,7 +7587,7 @@
                   <a:srgbClr val="203B31"/>
                 </a:solidFill>
               </a:rPr>
-              <a:t>Qwen2.5-1.5B-Instruct</a:t>
+              <a:t>IBM Granite 3.3 2B Instruct</a:t>
             </a:r>
           </a:p>
           <a:p xmlns:a="http://schemas.openxmlformats.org/drawingml/2006/main">
@@ -7604,7 +7604,7 @@
                   <a:srgbClr val="203B31"/>
                 </a:solidFill>
               </a:rPr>
-              <a:t>Official Q4_K_M GGUF</a:t>
+              <a:t>Official IBM Q4_K_M GGUF</a:t>
             </a:r>
           </a:p>
           <a:p xmlns:a="http://schemas.openxmlformats.org/drawingml/2006/main">
@@ -7638,7 +7638,7 @@
                   <a:srgbClr val="203B31"/>
                 </a:solidFill>
               </a:rPr>
-              <a:t>No fine-tuning</a:t>
+              <a:t>No team fine-tuning</a:t>
             </a:r>
           </a:p>
         </p:txBody>
@@ -8598,7 +8598,7 @@
         </p:xfrm>
         <a:graphic xmlns:a="http://schemas.openxmlformats.org/drawingml/2006/main">
           <a:graphicData uri="http://schemas.openxmlformats.org/drawingml/2006/chart">
-            <c:chart xmlns:r="http://schemas.openxmlformats.org/officeDocument/2006/relationships" xmlns:c="http://schemas.openxmlformats.org/drawingml/2006/chart" r:id="Rafbfab4d6b4d4895"/>
+            <c:chart xmlns:r="http://schemas.openxmlformats.org/officeDocument/2006/relationships" xmlns:c="http://schemas.openxmlformats.org/drawingml/2006/chart" r:id="R164a6f9fef554254"/>
           </a:graphicData>
         </a:graphic>
       </p:graphicFrame>
@@ -9397,7 +9397,7 @@
                   <a:srgbClr val="245B48"/>
                 </a:solidFill>
               </a:rPr>
-              <a:t>Live app: thehun-modem-weight-moving.trycloudflare.com</a:t>
+              <a:t>Live app: sewing-chef-mitsubishi-picked.trycloudflare.com</a:t>
             </a:r>
           </a:p>
           <a:p xmlns:a="http://schemas.openxmlformats.org/drawingml/2006/main">

</xml_diff>